<commit_message>
Update Parent Briefing Pack: School History Department header, Dr Kirkup & Mrs Lushey, refined catering, rooming & logistics
</commit_message>
<xml_diff>
--- a/public/briefings/ypres_2026_parent_briefing.pptx
+++ b/public/briefings/ypres_2026_parent_briefing.pptx
@@ -1137,7 +1137,7 @@
               <a:buNone/>
             </a:pPr>
             <a:r>
-              <a:rPr lang="en-US" sz="1100" b="1" dirty="0">
+              <a:rPr lang="en-US" sz="1050" b="1" dirty="0">
                 <a:solidFill>
                   <a:srgbClr val="F59E0B"/>
                 </a:solidFill>
@@ -1145,9 +1145,9 @@
                 <a:ea typeface="Arial" pitchFamily="34" charset="-122"/>
                 <a:cs typeface="Arial" pitchFamily="34" charset="-120"/>
               </a:rPr>
-              <a:t>Meoncross School History Department &amp; The History Boys  ·  Mr Ben Lovett &amp; Mr James Garrett</a:t>
-            </a:r>
-            <a:endParaRPr lang="en-US" sz="1100" dirty="0"/>
+              <a:t>Meoncross School History Department &amp; The History Boys · Mr B. Lovett &amp; Mr J. Garrett (Leaders) · Dr Kirkup &amp; Mrs Lushey</a:t>
+            </a:r>
+            <a:endParaRPr lang="en-US" sz="1050" dirty="0"/>
           </a:p>
         </p:txBody>
       </p:sp>
@@ -1331,7 +1331,7 @@
               <a:t>• 06:15 departure from Meoncross School.
 • Essex Farm ADS (John McCrae dugout).
 • Yorkshire Trench &amp; Langemarck Cemetery.
-• Evening: Check-in &amp; 2-course group dinner.
+• Evening: Check-in &amp; 2-course dinner at hostel.
 </a:t>
             </a:r>
             <a:pPr indent="0" marL="0">
@@ -1368,8 +1368,9 @@
                 <a:cs typeface="Arial" pitchFamily="34" charset="-120"/>
               </a:rPr>
               <a:t>• Vancouver Corner &amp; Hooge Crater trenches.
+• Supermarket lunch stop in the Salient.
 • Tyne Cot (finding our village fallen).
-• 20:00 Menin Gate Last Post &amp; wreath laying.
+• 2-course hostel dinner before 20:00 Last Post.
 </a:t>
             </a:r>
             <a:pPr indent="0" marL="0">
@@ -1589,9 +1590,9 @@
                 <a:ea typeface="Arial" pitchFamily="34" charset="-122"/>
                 <a:cs typeface="Arial" pitchFamily="34" charset="-120"/>
               </a:rPr>
-              <a:t>• Thursday Day 1: Pupils MUST bring a packed lunch &amp; coach snacks from home.
-• Full hot breakfast included (Fri &amp; Sat mornings).
-• 2-course evening group dinners (Thu &amp; Fri).
+              <a:t>• Thu Day 1: Bring packed lunch from home.
+• Buffet breakfasts at hostel (Fri &amp; Sat mornings).
+• 2-course dinners served on-site at Peace Village.
 </a:t>
             </a:r>
             <a:pPr indent="0" marL="0">
@@ -1627,8 +1628,8 @@
                 <a:ea typeface="Arial" pitchFamily="34" charset="-122"/>
                 <a:cs typeface="Arial" pitchFamily="34" charset="-120"/>
               </a:rPr>
-              <a:t>• Pupils need €20 to €30 in cash.
-• Used for supermarket lunch stops on Friday and Saturday (sandwiches/drinks) and souvenirs.
+              <a:t>• Pupils need €30 to €40 in cash (Euros).
+• Used for supermarket lunch stops on Friday and Saturday, chocolates &amp; souvenirs.
 </a:t>
             </a:r>
             <a:pPr indent="0" marL="0">
@@ -1684,7 +1685,7 @@
                 <a:ea typeface="Arial" pitchFamily="34" charset="-122"/>
                 <a:cs typeface="Arial" pitchFamily="34" charset="-120"/>
               </a:rPr>
-              <a:t>• En-suite rooms (3-4 pupils). Safe &amp; secure.</a:t>
+              <a:t>• Ensuite rooms (4-7 pupils, bunk beds).</a:t>
             </a:r>
             <a:endParaRPr lang="en-US" sz="950" dirty="0"/>
           </a:p>
@@ -1704,7 +1705,7 @@
                 <a:ea typeface="Arial" pitchFamily="34" charset="-122"/>
                 <a:cs typeface="Arial" pitchFamily="34" charset="-120"/>
               </a:rPr>
-              <a:t>• Rooming process begins in TWO WEEKS with student preference forms. Staff room checks.</a:t>
+              <a:t>• Rooming organized in ~2 weeks with friend nominations. Staff on same corridors.</a:t>
             </a:r>
             <a:endParaRPr lang="en-US" sz="950" dirty="0"/>
           </a:p>
@@ -1851,7 +1852,7 @@
               <a:t>• Sturdy walking boots / waterproof shoes.
 • Waterproof hooded rain jacket &amp; warm fleece.
 • Warm hat &amp; gloves (vital for evening ceremony!).
-• Change of socks &amp; casual clothes for dinner.
+• Casual clothes for evenings (no formal wear).
 • 1 medium holdall/case + 1 small daypack.
 </a:t>
             </a:r>
@@ -1888,8 +1889,8 @@
                 <a:ea typeface="Arial" pitchFamily="34" charset="-122"/>
                 <a:cs typeface="Arial" pitchFamily="34" charset="-120"/>
               </a:rPr>
-              <a:t>• Valid UK Passport (3+ months validity).
-• GHIC / EHIC health insurance card.
+              <a:t>• Passports &amp; GHIC: Collected tonight!
+• Mobiles collected in staff bag each evening.
 • UK-to-EU 2-pin plug adapter for chargers.
 </a:t>
             </a:r>
@@ -1926,27 +1927,7 @@
                 <a:ea typeface="Arial" pitchFamily="34" charset="-122"/>
                 <a:cs typeface="Arial" pitchFamily="34" charset="-120"/>
               </a:rPr>
-              <a:t>• Code of Conduct Agreement.</a:t>
-            </a:r>
-            <a:endParaRPr lang="en-US" sz="950" dirty="0"/>
-          </a:p>
-          <a:p>
-            <a:pPr indent="0" marL="0">
-              <a:lnSpc>
-                <a:spcPct val="105000"/>
-              </a:lnSpc>
-              <a:buNone/>
-            </a:pPr>
-            <a:r>
-              <a:rPr lang="en-US" sz="850" dirty="0">
-                <a:solidFill>
-                  <a:srgbClr val="334155"/>
-                </a:solidFill>
-                <a:latin typeface="Arial" pitchFamily="34" charset="0"/>
-                <a:ea typeface="Arial" pitchFamily="34" charset="-122"/>
-                <a:cs typeface="Arial" pitchFamily="34" charset="-120"/>
-              </a:rPr>
-              <a:t>• Medical &amp; Dietary Needs confirmation form.</a:t>
+              <a:t>• Code of Conduct Agreement (by Fri 25 Sep).</a:t>
             </a:r>
             <a:endParaRPr lang="en-US" sz="950" dirty="0"/>
           </a:p>
@@ -2029,7 +2010,7 @@
                 <a:ea typeface="Arial" pitchFamily="34" charset="-122"/>
                 <a:cs typeface="Arial" pitchFamily="34" charset="-120"/>
               </a:rPr>
-              <a:t>LIVE INTERACTIVE FIELD GUIDE &amp; APP:  meoncross-history.netlify.app</a:t>
+              <a:t>INTERACTIVE DIGITAL FIELD GUIDE:  meoncross-history.netlify.app</a:t>
             </a:r>
             <a:endParaRPr lang="en-US" sz="1050" dirty="0"/>
           </a:p>
@@ -2068,7 +2049,7 @@
                 <a:ea typeface="Arial" pitchFamily="34" charset="-122"/>
                 <a:cs typeface="Arial" pitchFamily="34" charset="-120"/>
               </a:rPr>
-              <a:t>Scan QR or visit URL to view full 3-day itinerary, poetry anthology, audio guides &amp; live family photo updates</a:t>
+              <a:t>Scan QR or visit URL to explore full 3-day itinerary, poetry anthology, historical dossiers &amp; cemetery maps</a:t>
             </a:r>
             <a:endParaRPr lang="en-US" sz="850" dirty="0"/>
           </a:p>
@@ -2641,7 +2622,7 @@
                 <a:ea typeface="Arial" pitchFamily="34" charset="-122"/>
                 <a:cs typeface="Arial" pitchFamily="34" charset="-120"/>
               </a:rPr>
-              <a:t>• Evening Clothes: </a:t>
+              <a:t>• Casual Clothes: </a:t>
             </a:r>
             <a:pPr indent="0" marL="0">
               <a:lnSpc>
@@ -2658,7 +2639,7 @@
                 <a:ea typeface="Arial" pitchFamily="34" charset="-122"/>
                 <a:cs typeface="Arial" pitchFamily="34" charset="-120"/>
               </a:rPr>
-              <a:t>Casual, clean clothing for restaurant dinners.
+              <a:t>Practical, comfortable clothing for downtime at hostel. No restaurant wear.
 </a:t>
             </a:r>
             <a:pPr indent="0" marL="0">
@@ -2799,7 +2780,7 @@
                 <a:ea typeface="Arial" pitchFamily="34" charset="-122"/>
                 <a:cs typeface="Arial" pitchFamily="34" charset="-120"/>
               </a:rPr>
-              <a:t>• Valid UK Passport: </a:t>
+              <a:t>• Valid UK Passport &amp; GHIC/EHIC: </a:t>
             </a:r>
             <a:pPr indent="0" marL="0">
               <a:lnSpc>
@@ -2816,42 +2797,7 @@
                 <a:ea typeface="Arial" pitchFamily="34" charset="-122"/>
                 <a:cs typeface="Arial" pitchFamily="34" charset="-120"/>
               </a:rPr>
-              <a:t>Must have at least 3 months validity beyond 3rd Oct 2026.
-</a:t>
-            </a:r>
-            <a:pPr indent="0" marL="0">
-              <a:lnSpc>
-                <a:spcPct val="108000"/>
-              </a:lnSpc>
-              <a:buNone/>
-            </a:pPr>
-            <a:r>
-              <a:rPr lang="en-US" sz="900" b="1" dirty="0">
-                <a:solidFill>
-                  <a:srgbClr val="334155"/>
-                </a:solidFill>
-                <a:latin typeface="Arial" pitchFamily="34" charset="0"/>
-                <a:ea typeface="Arial" pitchFamily="34" charset="-122"/>
-                <a:cs typeface="Arial" pitchFamily="34" charset="-120"/>
-              </a:rPr>
-              <a:t>• GHIC / Valid EHIC Card: </a:t>
-            </a:r>
-            <a:pPr indent="0" marL="0">
-              <a:lnSpc>
-                <a:spcPct val="108000"/>
-              </a:lnSpc>
-              <a:buNone/>
-            </a:pPr>
-            <a:r>
-              <a:rPr lang="en-US" sz="900" dirty="0">
-                <a:solidFill>
-                  <a:srgbClr val="334155"/>
-                </a:solidFill>
-                <a:latin typeface="Arial" pitchFamily="34" charset="0"/>
-                <a:ea typeface="Arial" pitchFamily="34" charset="-122"/>
-                <a:cs typeface="Arial" pitchFamily="34" charset="-120"/>
-              </a:rPr>
-              <a:t>Essential for reciprocal medical coverage in Belgium.
+              <a:t>Collected in advance tonight at briefing by Mr Lovett!
 </a:t>
             </a:r>
             <a:pPr indent="0" marL="0">
@@ -2921,7 +2867,7 @@
                 <a:ea typeface="Arial" pitchFamily="34" charset="-122"/>
                 <a:cs typeface="Arial" pitchFamily="34" charset="-120"/>
               </a:rPr>
-              <a:t>Permitted for camera, web app &amp; parent calls. Silent at memorials.</a:t>
+              <a:t>Permitted by day; collected in dedicated staff phone bag each evening at curfew.</a:t>
             </a:r>
             <a:endParaRPr lang="en-US" sz="900" dirty="0"/>
           </a:p>
@@ -3079,7 +3025,7 @@
                 <a:ea typeface="Arial" pitchFamily="34" charset="-122"/>
                 <a:cs typeface="Arial" pitchFamily="34" charset="-120"/>
               </a:rPr>
-              <a:t>€20–€30 in cash for Friday &amp; Saturday supermarket lunches.
+              <a:t>€30–€40 in cash for Friday &amp; Saturday supermarket lunches &amp; souvenirs.
 </a:t>
             </a:r>
             <a:pPr indent="0" marL="0">
@@ -3097,7 +3043,7 @@
                 <a:ea typeface="Arial" pitchFamily="34" charset="-122"/>
                 <a:cs typeface="Arial" pitchFamily="34" charset="-120"/>
               </a:rPr>
-              <a:t>• Rooming Preference Forms: </a:t>
+              <a:t>• Accommodation &amp; Rooming: </a:t>
             </a:r>
             <a:pPr indent="0" marL="0">
               <a:lnSpc>
@@ -3114,7 +3060,7 @@
                 <a:ea typeface="Arial" pitchFamily="34" charset="-122"/>
                 <a:cs typeface="Arial" pitchFamily="34" charset="-120"/>
               </a:rPr>
-              <a:t>Distributed in school in 2 weeks. 3-4 pupils per en-suite room.
+              <a:t>Peace Village Hostel (4-7 per room, bunk beds). Organized in ~2 weeks.
 </a:t>
             </a:r>
             <a:pPr indent="0" marL="0">
@@ -3149,7 +3095,7 @@
                 <a:ea typeface="Arial" pitchFamily="34" charset="-122"/>
                 <a:cs typeface="Arial" pitchFamily="34" charset="-120"/>
               </a:rPr>
-              <a:t>Code of Conduct &amp; Medical form due Friday 25th September.</a:t>
+              <a:t>Code of Conduct Agreement due Friday 25th September.</a:t>
             </a:r>
             <a:endParaRPr lang="en-US" sz="900" dirty="0"/>
           </a:p>
@@ -3188,7 +3134,7 @@
                 <a:ea typeface="Arial" pitchFamily="34" charset="-122"/>
                 <a:cs typeface="Arial" pitchFamily="34" charset="-120"/>
               </a:rPr>
-              <a:t>Joint Expedition Leadership: Mr Ben Lovett (Meoncross School) &amp; Mr James Garrett (The History Boys)</a:t>
+              <a:t>Expedition Staff: Mr Ben Lovett &amp; Mr James Garrett (Tour Leaders) · Dr Kirkup &amp; Mrs Lushey (Accompanying Staff)</a:t>
             </a:r>
             <a:endParaRPr lang="en-US" sz="950" dirty="0"/>
           </a:p>
@@ -3565,7 +3511,7 @@
                 <a:ea typeface="Arial" pitchFamily="34" charset="-122"/>
                 <a:cs typeface="Arial" pitchFamily="34" charset="-120"/>
               </a:rPr>
-              <a:t>"How did three young brothers from one Lee-on-the-Solent family find their resting places scattered across the battlefields of Europe and Turkey?"</a:t>
+              <a:t>"How did three sons from one coastal Hampshire family answer the call across Gallipoli, Arras, and the Somme—and how did six young men from our quiet village come to rest upon the ramparts and mud of Flanders?"</a:t>
             </a:r>
             <a:endParaRPr lang="en-US" sz="950" dirty="0"/>
           </a:p>

</xml_diff>

<commit_message>
Synchronise exact tour itinerary across PowerPoint, Parent Pack, Pupil Field Guide, and Teacher Companion
</commit_message>
<xml_diff>
--- a/public/briefings/ypres_2026_parent_briefing.pptx
+++ b/public/briefings/ypres_2026_parent_briefing.pptx
@@ -1310,7 +1310,7 @@
                 <a:ea typeface="Arial" pitchFamily="34" charset="-122"/>
                 <a:cs typeface="Arial" pitchFamily="34" charset="-120"/>
               </a:rPr>
-              <a:t>Day 1: North Salient &amp; Medical Triage
+              <a:t>Day 1: North Salient &amp; Mine Warfare
 </a:t>
             </a:r>
             <a:pPr indent="0" marL="0">
@@ -1320,18 +1320,18 @@
               <a:buNone/>
             </a:pPr>
             <a:r>
-              <a:rPr lang="en-US" sz="850" dirty="0">
-                <a:solidFill>
-                  <a:srgbClr val="334155"/>
-                </a:solidFill>
-                <a:latin typeface="Arial" pitchFamily="34" charset="0"/>
-                <a:ea typeface="Arial" pitchFamily="34" charset="-122"/>
-                <a:cs typeface="Arial" pitchFamily="34" charset="-120"/>
-              </a:rPr>
-              <a:t>• 06:15 departure from Meoncross School.
-• Essex Farm ADS (John McCrae dugout).
-• Yorkshire Trench &amp; Langemarck Cemetery.
-• Evening: Check-in &amp; 2-course dinner at hostel.
+              <a:rPr lang="en-US" sz="820" dirty="0">
+                <a:solidFill>
+                  <a:srgbClr val="334155"/>
+                </a:solidFill>
+                <a:latin typeface="Arial" pitchFamily="34" charset="0"/>
+                <a:ea typeface="Arial" pitchFamily="34" charset="-122"/>
+                <a:cs typeface="Arial" pitchFamily="34" charset="-120"/>
+              </a:rPr>
+              <a:t>• 06:15 departure from Meoncross School (Jet Connect).
+• 11:20 Eurotunnel; 14:30 Essex Farm ADS (Valentine Strudwick).
+• 15:15 Langemarck &amp; 16:00 Hooge Crater Museum.
+• 17:45 Peace Village, 18:15 dinner &amp; 19:15 classroom debrief.
 </a:t>
             </a:r>
             <a:pPr indent="0" marL="0">
@@ -1349,7 +1349,7 @@
                 <a:ea typeface="Arial" pitchFamily="34" charset="-122"/>
                 <a:cs typeface="Arial" pitchFamily="34" charset="-120"/>
               </a:rPr>
-              <a:t>Day 2: Passchendaele &amp; Menin Gate
+              <a:t>Day 2: Passchendaele, Medical Sites &amp; Last Post
 </a:t>
             </a:r>
             <a:pPr indent="0" marL="0">
@@ -1359,18 +1359,18 @@
               <a:buNone/>
             </a:pPr>
             <a:r>
-              <a:rPr lang="en-US" sz="850" dirty="0">
-                <a:solidFill>
-                  <a:srgbClr val="334155"/>
-                </a:solidFill>
-                <a:latin typeface="Arial" pitchFamily="34" charset="0"/>
-                <a:ea typeface="Arial" pitchFamily="34" charset="-122"/>
-                <a:cs typeface="Arial" pitchFamily="34" charset="-120"/>
-              </a:rPr>
-              <a:t>• Vancouver Corner &amp; Hooge Crater trenches.
-• Supermarket lunch stop in the Salient.
-• Tyne Cot (finding our village fallen).
-• 2-course hostel dinner before 20:00 Last Post.
+              <a:rPr lang="en-US" sz="820" dirty="0">
+                <a:solidFill>
+                  <a:srgbClr val="334155"/>
+                </a:solidFill>
+                <a:latin typeface="Arial" pitchFamily="34" charset="0"/>
+                <a:ea typeface="Arial" pitchFamily="34" charset="-122"/>
+                <a:cs typeface="Arial" pitchFamily="34" charset="-120"/>
+              </a:rPr>
+              <a:t>• 09:15 Brooding Soldier &amp; 09:45 Sanctuary Wood.
+• 11:30 Aldi Ypres lunch stop; 13:00 Tyne Cot (our fallen).
+• 14:15 Lijssenthoek CCS &amp; 15:45 Passchendaele Museum.
+• 18:00 dinner; 19:20 arrive Menin Gate for 20:00 Last Post.
 </a:t>
             </a:r>
             <a:pPr indent="0" marL="0">
@@ -1388,7 +1388,7 @@
                 <a:ea typeface="Arial" pitchFamily="34" charset="-122"/>
                 <a:cs typeface="Arial" pitchFamily="34" charset="-120"/>
               </a:rPr>
-              <a:t>Day 3: Ypres Town &amp; Journey Home
+              <a:t>Day 3: Ypres Daylight, Talbot House &amp; Return
 </a:t>
             </a:r>
             <a:pPr indent="0" marL="0">
@@ -1398,15 +1398,15 @@
               <a:buNone/>
             </a:pPr>
             <a:r>
-              <a:rPr lang="en-US" sz="850" dirty="0">
-                <a:solidFill>
-                  <a:srgbClr val="334155"/>
-                </a:solidFill>
-                <a:latin typeface="Arial" pitchFamily="34" charset="0"/>
-                <a:ea typeface="Arial" pitchFamily="34" charset="-122"/>
-                <a:cs typeface="Arial" pitchFamily="34" charset="-120"/>
-              </a:rPr>
-              <a:t>• In Flanders Fields Museum (Cloth Hall).</a:t>
+              <a:rPr lang="en-US" sz="820" dirty="0">
+                <a:solidFill>
+                  <a:srgbClr val="334155"/>
+                </a:solidFill>
+                <a:latin typeface="Arial" pitchFamily="34" charset="0"/>
+                <a:ea typeface="Arial" pitchFamily="34" charset="-122"/>
+                <a:cs typeface="Arial" pitchFamily="34" charset="-120"/>
+              </a:rPr>
+              <a:t>• 09:15 Menin Gate &amp; Ramparts walk.</a:t>
             </a:r>
             <a:endParaRPr lang="en-US" sz="950" dirty="0"/>
           </a:p>
@@ -1418,15 +1418,15 @@
               <a:buNone/>
             </a:pPr>
             <a:r>
-              <a:rPr lang="en-US" sz="850" dirty="0">
-                <a:solidFill>
-                  <a:srgbClr val="334155"/>
-                </a:solidFill>
-                <a:latin typeface="Arial" pitchFamily="34" charset="0"/>
-                <a:ea typeface="Arial" pitchFamily="34" charset="-122"/>
-                <a:cs typeface="Arial" pitchFamily="34" charset="-120"/>
-              </a:rPr>
-              <a:t>• Ramparts Walk &amp; Talbot House (Poperinge).</a:t>
+              <a:rPr lang="en-US" sz="820" dirty="0">
+                <a:solidFill>
+                  <a:srgbClr val="334155"/>
+                </a:solidFill>
+                <a:latin typeface="Arial" pitchFamily="34" charset="0"/>
+                <a:ea typeface="Arial" pitchFamily="34" charset="-122"/>
+                <a:cs typeface="Arial" pitchFamily="34" charset="-120"/>
+              </a:rPr>
+              <a:t>• 10:30 De Groote’s Chocolatier (Grote Markt; €30–€40 envelope).</a:t>
             </a:r>
             <a:endParaRPr lang="en-US" sz="950" dirty="0"/>
           </a:p>
@@ -1438,15 +1438,35 @@
               <a:buNone/>
             </a:pPr>
             <a:r>
-              <a:rPr lang="en-US" sz="850" dirty="0">
-                <a:solidFill>
-                  <a:srgbClr val="334155"/>
-                </a:solidFill>
-                <a:latin typeface="Arial" pitchFamily="34" charset="0"/>
-                <a:ea typeface="Arial" pitchFamily="34" charset="-122"/>
-                <a:cs typeface="Arial" pitchFamily="34" charset="-120"/>
-              </a:rPr>
-              <a:t>• Supermarket lunch stop &amp; return approx 20:30.</a:t>
+              <a:rPr lang="en-US" sz="820" dirty="0">
+                <a:solidFill>
+                  <a:srgbClr val="334155"/>
+                </a:solidFill>
+                <a:latin typeface="Arial" pitchFamily="34" charset="0"/>
+                <a:ea typeface="Arial" pitchFamily="34" charset="-122"/>
+                <a:cs typeface="Arial" pitchFamily="34" charset="-120"/>
+              </a:rPr>
+              <a:t>• 11:20 Talbot House, 12:45 lunch, 13:30 Town Hall Death Cells.</a:t>
+            </a:r>
+            <a:endParaRPr lang="en-US" sz="950" dirty="0"/>
+          </a:p>
+          <a:p>
+            <a:pPr indent="0" marL="0">
+              <a:lnSpc>
+                <a:spcPct val="105000"/>
+              </a:lnSpc>
+              <a:buNone/>
+            </a:pPr>
+            <a:r>
+              <a:rPr lang="en-US" sz="820" dirty="0">
+                <a:solidFill>
+                  <a:srgbClr val="334155"/>
+                </a:solidFill>
+                <a:latin typeface="Arial" pitchFamily="34" charset="0"/>
+                <a:ea typeface="Arial" pitchFamily="34" charset="-122"/>
+                <a:cs typeface="Arial" pitchFamily="34" charset="-120"/>
+              </a:rPr>
+              <a:t>• 14:30 depart for Calais; arrive school approx 20:00.</a:t>
             </a:r>
             <a:endParaRPr lang="en-US" sz="950" dirty="0"/>
           </a:p>

</xml_diff>

<commit_message>
Update Ypres tour briefing PPTX, PDFs, and database with authentic Stubbington fallen and anonymized staff
</commit_message>
<xml_diff>
--- a/public/briefings/ypres_2026_parent_briefing.pptx
+++ b/public/briefings/ypres_2026_parent_briefing.pptx
@@ -1145,7 +1145,7 @@
                 <a:ea typeface="Arial" pitchFamily="34" charset="-122"/>
                 <a:cs typeface="Arial" pitchFamily="34" charset="-120"/>
               </a:rPr>
-              <a:t>Meoncross School History Department &amp; The History Boys · Mr B. Lovett &amp; Mr J. Garrett (Leaders) · Dr Kirkup &amp; Mrs Lushey</a:t>
+              <a:t>Meoncross School History Department &amp; The History Boys · Mr B. Lovett &amp; Mr J. Garrett (Leaders) · Accompanied by Two Meoncross Staff</a:t>
             </a:r>
             <a:endParaRPr lang="en-US" sz="1050" dirty="0"/>
           </a:p>
@@ -3154,7 +3154,7 @@
                 <a:ea typeface="Arial" pitchFamily="34" charset="-122"/>
                 <a:cs typeface="Arial" pitchFamily="34" charset="-120"/>
               </a:rPr>
-              <a:t>Expedition Staff: Mr Ben Lovett &amp; Mr James Garrett (Tour Leaders) · Dr Kirkup &amp; Mrs Lushey (Accompanying Staff)</a:t>
+              <a:t>Expedition Staff: Mr Ben Lovett &amp; Mr James Garrett (Tour Leaders) · Accompanied by Two Meoncross Staff</a:t>
             </a:r>
             <a:endParaRPr lang="en-US" sz="950" dirty="0"/>
           </a:p>

</xml_diff>

<commit_message>
feat(trip_ypres): update parent briefing kit with mandatory towels, shower gel, and Sanctuary Wood boots and plastic bag
</commit_message>
<xml_diff>
--- a/public/briefings/ypres_2026_parent_briefing.pptx
+++ b/public/briefings/ypres_2026_parent_briefing.pptx
@@ -1869,9 +1869,9 @@
                 <a:ea typeface="Arial" pitchFamily="34" charset="-122"/>
                 <a:cs typeface="Arial" pitchFamily="34" charset="-120"/>
               </a:rPr>
-              <a:t>• Sturdy walking boots / waterproof shoes.
-• Waterproof hooded rain jacket &amp; warm fleece.
-• Warm hat &amp; gloves (vital for evening ceremony!).
+              <a:t>• Sanctuary Wood: boots/wellies + spare shoes &amp; plastic bag.
+• Bath towels &amp; washbag (shower gel; roll-on only).
+• Waterproof hooded jacket, warm fleece, hat &amp; gloves.
 • Casual clothes for evenings (no formal wear).
 • 1 medium holdall/case + 1 small daypack.
 </a:t>
@@ -2302,7 +2302,7 @@
                 <a:ea typeface="Arial" pitchFamily="34" charset="-122"/>
                 <a:cs typeface="Arial" pitchFamily="34" charset="-120"/>
               </a:rPr>
-              <a:t>🥾 FOOTWEAR &amp; WEATHER PROTECTION</a:t>
+              <a:t>🥾 FOOTWEAR &amp; SANCTUARY WOOD PREPARATION</a:t>
             </a:r>
             <a:endParaRPr lang="en-US" sz="1100" dirty="0"/>
           </a:p>
@@ -2331,47 +2331,82 @@
           <a:p>
             <a:pPr indent="0" marL="0">
               <a:lnSpc>
-                <a:spcPct val="108000"/>
-              </a:lnSpc>
-              <a:buNone/>
-            </a:pPr>
-            <a:r>
-              <a:rPr lang="en-US" sz="900" b="1" dirty="0">
-                <a:solidFill>
-                  <a:srgbClr val="334155"/>
-                </a:solidFill>
-                <a:latin typeface="Arial" pitchFamily="34" charset="0"/>
-                <a:ea typeface="Arial" pitchFamily="34" charset="-122"/>
-                <a:cs typeface="Arial" pitchFamily="34" charset="-120"/>
-              </a:rPr>
-              <a:t>• Walking Boots / Shoes: </a:t>
-            </a:r>
-            <a:pPr indent="0" marL="0">
-              <a:lnSpc>
-                <a:spcPct val="108000"/>
-              </a:lnSpc>
-              <a:buNone/>
-            </a:pPr>
-            <a:r>
-              <a:rPr lang="en-US" sz="900" dirty="0">
-                <a:solidFill>
-                  <a:srgbClr val="334155"/>
-                </a:solidFill>
-                <a:latin typeface="Arial" pitchFamily="34" charset="0"/>
-                <a:ea typeface="Arial" pitchFamily="34" charset="-122"/>
-                <a:cs typeface="Arial" pitchFamily="34" charset="-120"/>
-              </a:rPr>
-              <a:t>Must be sturdy, comfortable &amp; broken-in. Flanders mud can be slippery.
+                <a:spcPct val="105000"/>
+              </a:lnSpc>
+              <a:buNone/>
+            </a:pPr>
+            <a:r>
+              <a:rPr lang="en-US" sz="850" b="1" dirty="0">
+                <a:solidFill>
+                  <a:srgbClr val="334155"/>
+                </a:solidFill>
+                <a:latin typeface="Arial" pitchFamily="34" charset="0"/>
+                <a:ea typeface="Arial" pitchFamily="34" charset="-122"/>
+                <a:cs typeface="Arial" pitchFamily="34" charset="-120"/>
+              </a:rPr>
+              <a:t>• Sanctuary Wood Trenches: </a:t>
+            </a:r>
+            <a:pPr indent="0" marL="0">
+              <a:lnSpc>
+                <a:spcPct val="105000"/>
+              </a:lnSpc>
+              <a:buNone/>
+            </a:pPr>
+            <a:r>
+              <a:rPr lang="en-US" sz="850" dirty="0">
+                <a:solidFill>
+                  <a:srgbClr val="334155"/>
+                </a:solidFill>
+                <a:latin typeface="Arial" pitchFamily="34" charset="0"/>
+                <a:ea typeface="Arial" pitchFamily="34" charset="-122"/>
+                <a:cs typeface="Arial" pitchFamily="34" charset="-120"/>
+              </a:rPr>
+              <a:t>Real, muddy frontline trenches. Must bring boots/wellies!
 </a:t>
             </a:r>
             <a:pPr indent="0" marL="0">
               <a:lnSpc>
-                <a:spcPct val="108000"/>
-              </a:lnSpc>
-              <a:buNone/>
-            </a:pPr>
-            <a:r>
-              <a:rPr lang="en-US" sz="900" b="1" dirty="0">
+                <a:spcPct val="105000"/>
+              </a:lnSpc>
+              <a:buNone/>
+            </a:pPr>
+            <a:r>
+              <a:rPr lang="en-US" sz="850" b="1" dirty="0">
+                <a:solidFill>
+                  <a:srgbClr val="334155"/>
+                </a:solidFill>
+                <a:latin typeface="Arial" pitchFamily="34" charset="0"/>
+                <a:ea typeface="Arial" pitchFamily="34" charset="-122"/>
+                <a:cs typeface="Arial" pitchFamily="34" charset="-120"/>
+              </a:rPr>
+              <a:t>• Separate Footwear &amp; Plastic Bag: </a:t>
+            </a:r>
+            <a:pPr indent="0" marL="0">
+              <a:lnSpc>
+                <a:spcPct val="105000"/>
+              </a:lnSpc>
+              <a:buNone/>
+            </a:pPr>
+            <a:r>
+              <a:rPr lang="en-US" sz="850" dirty="0">
+                <a:solidFill>
+                  <a:srgbClr val="334155"/>
+                </a:solidFill>
+                <a:latin typeface="Arial" pitchFamily="34" charset="0"/>
+                <a:ea typeface="Arial" pitchFamily="34" charset="-122"/>
+                <a:cs typeface="Arial" pitchFamily="34" charset="-120"/>
+              </a:rPr>
+              <a:t>Bring spare clean shoes/trainers + carrier bag for muddy boots.
+</a:t>
+            </a:r>
+            <a:pPr indent="0" marL="0">
+              <a:lnSpc>
+                <a:spcPct val="105000"/>
+              </a:lnSpc>
+              <a:buNone/>
+            </a:pPr>
+            <a:r>
+              <a:rPr lang="en-US" sz="850" b="1" dirty="0">
                 <a:solidFill>
                   <a:srgbClr val="334155"/>
                 </a:solidFill>
@@ -2383,12 +2418,12 @@
             </a:r>
             <a:pPr indent="0" marL="0">
               <a:lnSpc>
-                <a:spcPct val="108000"/>
-              </a:lnSpc>
-              <a:buNone/>
-            </a:pPr>
-            <a:r>
-              <a:rPr lang="en-US" sz="900" dirty="0">
+                <a:spcPct val="105000"/>
+              </a:lnSpc>
+              <a:buNone/>
+            </a:pPr>
+            <a:r>
+              <a:rPr lang="en-US" sz="850" dirty="0">
                 <a:solidFill>
                   <a:srgbClr val="334155"/>
                 </a:solidFill>
@@ -2401,29 +2436,29 @@
             </a:r>
             <a:pPr indent="0" marL="0">
               <a:lnSpc>
-                <a:spcPct val="108000"/>
-              </a:lnSpc>
-              <a:buNone/>
-            </a:pPr>
-            <a:r>
-              <a:rPr lang="en-US" sz="900" b="1" dirty="0">
-                <a:solidFill>
-                  <a:srgbClr val="334155"/>
-                </a:solidFill>
-                <a:latin typeface="Arial" pitchFamily="34" charset="0"/>
-                <a:ea typeface="Arial" pitchFamily="34" charset="-122"/>
-                <a:cs typeface="Arial" pitchFamily="34" charset="-120"/>
-              </a:rPr>
-              <a:t>• Warm Fleece / Mid-layer: </a:t>
-            </a:r>
-            <a:pPr indent="0" marL="0">
-              <a:lnSpc>
-                <a:spcPct val="108000"/>
-              </a:lnSpc>
-              <a:buNone/>
-            </a:pPr>
-            <a:r>
-              <a:rPr lang="en-US" sz="900" dirty="0">
+                <a:spcPct val="105000"/>
+              </a:lnSpc>
+              <a:buNone/>
+            </a:pPr>
+            <a:r>
+              <a:rPr lang="en-US" sz="850" b="1" dirty="0">
+                <a:solidFill>
+                  <a:srgbClr val="334155"/>
+                </a:solidFill>
+                <a:latin typeface="Arial" pitchFamily="34" charset="0"/>
+                <a:ea typeface="Arial" pitchFamily="34" charset="-122"/>
+                <a:cs typeface="Arial" pitchFamily="34" charset="-120"/>
+              </a:rPr>
+              <a:t>• Warm Fleece &amp; Layers: </a:t>
+            </a:r>
+            <a:pPr indent="0" marL="0">
+              <a:lnSpc>
+                <a:spcPct val="105000"/>
+              </a:lnSpc>
+              <a:buNone/>
+            </a:pPr>
+            <a:r>
+              <a:rPr lang="en-US" sz="850" dirty="0">
                 <a:solidFill>
                   <a:srgbClr val="334155"/>
                 </a:solidFill>
@@ -2436,12 +2471,12 @@
             </a:r>
             <a:pPr indent="0" marL="0">
               <a:lnSpc>
-                <a:spcPct val="108000"/>
-              </a:lnSpc>
-              <a:buNone/>
-            </a:pPr>
-            <a:r>
-              <a:rPr lang="en-US" sz="900" b="1" dirty="0">
+                <a:spcPct val="105000"/>
+              </a:lnSpc>
+              <a:buNone/>
+            </a:pPr>
+            <a:r>
+              <a:rPr lang="en-US" sz="850" b="1" dirty="0">
                 <a:solidFill>
                   <a:srgbClr val="334155"/>
                 </a:solidFill>
@@ -2453,12 +2488,12 @@
             </a:r>
             <a:pPr indent="0" marL="0">
               <a:lnSpc>
-                <a:spcPct val="108000"/>
-              </a:lnSpc>
-              <a:buNone/>
-            </a:pPr>
-            <a:r>
-              <a:rPr lang="en-US" sz="900" dirty="0">
+                <a:spcPct val="105000"/>
+              </a:lnSpc>
+              <a:buNone/>
+            </a:pPr>
+            <a:r>
+              <a:rPr lang="en-US" sz="850" dirty="0">
                 <a:solidFill>
                   <a:srgbClr val="334155"/>
                 </a:solidFill>
@@ -2468,7 +2503,7 @@
               </a:rPr>
               <a:t>Crucial for standing still during the 8:00 PM Menin Gate ceremony.</a:t>
             </a:r>
-            <a:endParaRPr lang="en-US" sz="900" dirty="0"/>
+            <a:endParaRPr lang="en-US" sz="850" dirty="0"/>
           </a:p>
         </p:txBody>
       </p:sp>
@@ -2530,7 +2565,7 @@
                 <a:ea typeface="Arial" pitchFamily="34" charset="-122"/>
                 <a:cs typeface="Arial" pitchFamily="34" charset="-120"/>
               </a:rPr>
-              <a:t>🎒 LUGGAGE &amp; DAYPACK RULES</a:t>
+              <a:t>🎒 LUGGAGE, TOWELS &amp; WASHBAG</a:t>
             </a:r>
             <a:endParaRPr lang="en-US" sz="1100" dirty="0"/>
           </a:p>
@@ -2559,47 +2594,117 @@
           <a:p>
             <a:pPr indent="0" marL="0">
               <a:lnSpc>
-                <a:spcPct val="108000"/>
-              </a:lnSpc>
-              <a:buNone/>
-            </a:pPr>
-            <a:r>
-              <a:rPr lang="en-US" sz="900" b="1" dirty="0">
-                <a:solidFill>
-                  <a:srgbClr val="334155"/>
-                </a:solidFill>
-                <a:latin typeface="Arial" pitchFamily="34" charset="0"/>
-                <a:ea typeface="Arial" pitchFamily="34" charset="-122"/>
-                <a:cs typeface="Arial" pitchFamily="34" charset="-120"/>
-              </a:rPr>
-              <a:t>• 1 Main Holdall / Medium Suitcase: </a:t>
-            </a:r>
-            <a:pPr indent="0" marL="0">
-              <a:lnSpc>
-                <a:spcPct val="108000"/>
-              </a:lnSpc>
-              <a:buNone/>
-            </a:pPr>
-            <a:r>
-              <a:rPr lang="en-US" sz="900" dirty="0">
-                <a:solidFill>
-                  <a:srgbClr val="334155"/>
-                </a:solidFill>
-                <a:latin typeface="Arial" pitchFamily="34" charset="0"/>
-                <a:ea typeface="Arial" pitchFamily="34" charset="-122"/>
-                <a:cs typeface="Arial" pitchFamily="34" charset="-120"/>
-              </a:rPr>
-              <a:t>Goes underneath in coach hold until arrival at hostel.
+                <a:spcPct val="105000"/>
+              </a:lnSpc>
+              <a:buNone/>
+            </a:pPr>
+            <a:r>
+              <a:rPr lang="en-US" sz="850" b="1" dirty="0">
+                <a:solidFill>
+                  <a:srgbClr val="334155"/>
+                </a:solidFill>
+                <a:latin typeface="Arial" pitchFamily="34" charset="0"/>
+                <a:ea typeface="Arial" pitchFamily="34" charset="-122"/>
+                <a:cs typeface="Arial" pitchFamily="34" charset="-120"/>
+              </a:rPr>
+              <a:t>• TOWELS (Mandatory): </a:t>
+            </a:r>
+            <a:pPr indent="0" marL="0">
+              <a:lnSpc>
+                <a:spcPct val="105000"/>
+              </a:lnSpc>
+              <a:buNone/>
+            </a:pPr>
+            <a:r>
+              <a:rPr lang="en-US" sz="850" dirty="0">
+                <a:solidFill>
+                  <a:srgbClr val="334155"/>
+                </a:solidFill>
+                <a:latin typeface="Arial" pitchFamily="34" charset="0"/>
+                <a:ea typeface="Arial" pitchFamily="34" charset="-122"/>
+                <a:cs typeface="Arial" pitchFamily="34" charset="-120"/>
+              </a:rPr>
+              <a:t>Pupils must bring their own bath/shower towel! (None provided).
 </a:t>
             </a:r>
             <a:pPr indent="0" marL="0">
               <a:lnSpc>
-                <a:spcPct val="108000"/>
-              </a:lnSpc>
-              <a:buNone/>
-            </a:pPr>
-            <a:r>
-              <a:rPr lang="en-US" sz="900" b="1" dirty="0">
+                <a:spcPct val="105000"/>
+              </a:lnSpc>
+              <a:buNone/>
+            </a:pPr>
+            <a:r>
+              <a:rPr lang="en-US" sz="850" b="1" dirty="0">
+                <a:solidFill>
+                  <a:srgbClr val="334155"/>
+                </a:solidFill>
+                <a:latin typeface="Arial" pitchFamily="34" charset="0"/>
+                <a:ea typeface="Arial" pitchFamily="34" charset="-122"/>
+                <a:cs typeface="Arial" pitchFamily="34" charset="-120"/>
+              </a:rPr>
+              <a:t>• Washbag &amp; Shower Gel: </a:t>
+            </a:r>
+            <a:pPr indent="0" marL="0">
+              <a:lnSpc>
+                <a:spcPct val="105000"/>
+              </a:lnSpc>
+              <a:buNone/>
+            </a:pPr>
+            <a:r>
+              <a:rPr lang="en-US" sz="850" dirty="0">
+                <a:solidFill>
+                  <a:srgbClr val="334155"/>
+                </a:solidFill>
+                <a:latin typeface="Arial" pitchFamily="34" charset="0"/>
+                <a:ea typeface="Arial" pitchFamily="34" charset="-122"/>
+                <a:cs typeface="Arial" pitchFamily="34" charset="-120"/>
+              </a:rPr>
+              <a:t>Shower gel, shampoo, toothbrush, roll-on deodorant (no aerosols).
+</a:t>
+            </a:r>
+            <a:pPr indent="0" marL="0">
+              <a:lnSpc>
+                <a:spcPct val="105000"/>
+              </a:lnSpc>
+              <a:buNone/>
+            </a:pPr>
+            <a:r>
+              <a:rPr lang="en-US" sz="850" b="1" dirty="0">
+                <a:solidFill>
+                  <a:srgbClr val="334155"/>
+                </a:solidFill>
+                <a:latin typeface="Arial" pitchFamily="34" charset="0"/>
+                <a:ea typeface="Arial" pitchFamily="34" charset="-122"/>
+                <a:cs typeface="Arial" pitchFamily="34" charset="-120"/>
+              </a:rPr>
+              <a:t>• 1 Main Holdall / Case: </a:t>
+            </a:r>
+            <a:pPr indent="0" marL="0">
+              <a:lnSpc>
+                <a:spcPct val="105000"/>
+              </a:lnSpc>
+              <a:buNone/>
+            </a:pPr>
+            <a:r>
+              <a:rPr lang="en-US" sz="850" dirty="0">
+                <a:solidFill>
+                  <a:srgbClr val="334155"/>
+                </a:solidFill>
+                <a:latin typeface="Arial" pitchFamily="34" charset="0"/>
+                <a:ea typeface="Arial" pitchFamily="34" charset="-122"/>
+                <a:cs typeface="Arial" pitchFamily="34" charset="-120"/>
+              </a:rPr>
+              <a:t>Goes underneath in coach hold until arrival at hostel (max 15kg).
+</a:t>
+            </a:r>
+            <a:pPr indent="0" marL="0">
+              <a:lnSpc>
+                <a:spcPct val="105000"/>
+              </a:lnSpc>
+              <a:buNone/>
+            </a:pPr>
+            <a:r>
+              <a:rPr lang="en-US" sz="850" b="1" dirty="0">
                 <a:solidFill>
                   <a:srgbClr val="334155"/>
                 </a:solidFill>
@@ -2611,30 +2716,30 @@
             </a:r>
             <a:pPr indent="0" marL="0">
               <a:lnSpc>
-                <a:spcPct val="108000"/>
-              </a:lnSpc>
-              <a:buNone/>
-            </a:pPr>
-            <a:r>
-              <a:rPr lang="en-US" sz="900" dirty="0">
-                <a:solidFill>
-                  <a:srgbClr val="334155"/>
-                </a:solidFill>
-                <a:latin typeface="Arial" pitchFamily="34" charset="0"/>
-                <a:ea typeface="Arial" pitchFamily="34" charset="-122"/>
-                <a:cs typeface="Arial" pitchFamily="34" charset="-120"/>
-              </a:rPr>
-              <a:t>Stays with student on coach. Contains waterproofs, water bottle, Day 1 packed lunch &amp; phone.
+                <a:spcPct val="105000"/>
+              </a:lnSpc>
+              <a:buNone/>
+            </a:pPr>
+            <a:r>
+              <a:rPr lang="en-US" sz="850" dirty="0">
+                <a:solidFill>
+                  <a:srgbClr val="334155"/>
+                </a:solidFill>
+                <a:latin typeface="Arial" pitchFamily="34" charset="0"/>
+                <a:ea typeface="Arial" pitchFamily="34" charset="-122"/>
+                <a:cs typeface="Arial" pitchFamily="34" charset="-120"/>
+              </a:rPr>
+              <a:t>Stays on coach. Holds waterproofs, plastic bag, packed lunch &amp; water.
 </a:t>
             </a:r>
             <a:pPr indent="0" marL="0">
               <a:lnSpc>
-                <a:spcPct val="108000"/>
-              </a:lnSpc>
-              <a:buNone/>
-            </a:pPr>
-            <a:r>
-              <a:rPr lang="en-US" sz="900" b="1" dirty="0">
+                <a:spcPct val="105000"/>
+              </a:lnSpc>
+              <a:buNone/>
+            </a:pPr>
+            <a:r>
+              <a:rPr lang="en-US" sz="850" b="1" dirty="0">
                 <a:solidFill>
                   <a:srgbClr val="334155"/>
                 </a:solidFill>
@@ -2646,57 +2751,22 @@
             </a:r>
             <a:pPr indent="0" marL="0">
               <a:lnSpc>
-                <a:spcPct val="108000"/>
-              </a:lnSpc>
-              <a:buNone/>
-            </a:pPr>
-            <a:r>
-              <a:rPr lang="en-US" sz="900" dirty="0">
-                <a:solidFill>
-                  <a:srgbClr val="334155"/>
-                </a:solidFill>
-                <a:latin typeface="Arial" pitchFamily="34" charset="0"/>
-                <a:ea typeface="Arial" pitchFamily="34" charset="-122"/>
-                <a:cs typeface="Arial" pitchFamily="34" charset="-120"/>
-              </a:rPr>
-              <a:t>Practical, comfortable clothing for downtime at hostel. No restaurant wear.
-</a:t>
-            </a:r>
-            <a:pPr indent="0" marL="0">
-              <a:lnSpc>
-                <a:spcPct val="108000"/>
-              </a:lnSpc>
-              <a:buNone/>
-            </a:pPr>
-            <a:r>
-              <a:rPr lang="en-US" sz="900" b="1" dirty="0">
-                <a:solidFill>
-                  <a:srgbClr val="334155"/>
-                </a:solidFill>
-                <a:latin typeface="Arial" pitchFamily="34" charset="0"/>
-                <a:ea typeface="Arial" pitchFamily="34" charset="-122"/>
-                <a:cs typeface="Arial" pitchFamily="34" charset="-120"/>
-              </a:rPr>
-              <a:t>• Nightwear &amp; Washbag: </a:t>
-            </a:r>
-            <a:pPr indent="0" marL="0">
-              <a:lnSpc>
-                <a:spcPct val="108000"/>
-              </a:lnSpc>
-              <a:buNone/>
-            </a:pPr>
-            <a:r>
-              <a:rPr lang="en-US" sz="900" dirty="0">
-                <a:solidFill>
-                  <a:srgbClr val="334155"/>
-                </a:solidFill>
-                <a:latin typeface="Arial" pitchFamily="34" charset="0"/>
-                <a:ea typeface="Arial" pitchFamily="34" charset="-122"/>
-                <a:cs typeface="Arial" pitchFamily="34" charset="-120"/>
-              </a:rPr>
-              <a:t>Towel, toothbrush, roll-on deodorant (no aerosols).</a:t>
-            </a:r>
-            <a:endParaRPr lang="en-US" sz="900" dirty="0"/>
+                <a:spcPct val="105000"/>
+              </a:lnSpc>
+              <a:buNone/>
+            </a:pPr>
+            <a:r>
+              <a:rPr lang="en-US" sz="850" dirty="0">
+                <a:solidFill>
+                  <a:srgbClr val="334155"/>
+                </a:solidFill>
+                <a:latin typeface="Arial" pitchFamily="34" charset="0"/>
+                <a:ea typeface="Arial" pitchFamily="34" charset="-122"/>
+                <a:cs typeface="Arial" pitchFamily="34" charset="-120"/>
+              </a:rPr>
+              <a:t>Comfortable clothing for downtime at hostel. No restaurant wear.</a:t>
+            </a:r>
+            <a:endParaRPr lang="en-US" sz="850" dirty="0"/>
           </a:p>
         </p:txBody>
       </p:sp>

</xml_diff>